<commit_message>
Conciliación: biblias verificadas, el grupo pagó las 52
El reembolso a JM del 19/08 es 35,360 = 52 × 680 exactos. El presupuesto
oficial solo contemplaba 50 (34,000) porque 2 las pagaría Camila
Fernández: esas 2 (1,360) quedaron dentro de lo que pagó el grupo. No hay
aporte suyo en las 49 donaciones ni ningún movimiento de 1,360.

Queda por confirmar con ella si puso el dinero de su bolsillo, para
reembolsarlo o registrarlo como donación en especie. La caja y el cuadre
con el banco no cambian en ningún caso.

Auditoría: 37/37. verify.py: 9/9 PASS.

Co-Authored-By: Claude Opus 5 <noreply@anthropic.com>
Claude-Session: https://claude.ai/code/session_016scja59CycFFrqKgYsUPWh
</commit_message>
<xml_diff>
--- a/data/presupuesto/Conciliacion_ETC88_Presentacion.pptx
+++ b/data/presupuesto/Conciliacion_ETC88_Presentacion.pptx
@@ -3759,7 +3759,7 @@
                   <a:srgbClr val="888888"/>
                 </a:solidFill>
               </a:rPr>
-              <a:t>Cifras en RD$ · 36 verificaciones numéricas recalculadas (36 PASS) · acompaña al Excel Conciliacion_Final_ETC88.xlsx</a:t>
+              <a:t>Cifras en RD$ · 37 verificaciones numéricas recalculadas (37 PASS) · acompaña al Excel Conciliacion_Final_ETC88.xlsx</a:t>
             </a:r>
           </a:p>
         </p:txBody>
@@ -3888,7 +3888,7 @@
                   <a:srgbClr val="888888"/>
                 </a:solidFill>
               </a:rPr>
-              <a:t>0 abiertos · 1 notas · el detalle completo está en la hoja 5 del Excel</a:t>
+              <a:t>0 abiertos · 2 notas · el detalle completo está en la hoja 5 del Excel</a:t>
             </a:r>
           </a:p>
         </p:txBody>
@@ -3937,7 +3937,7 @@
         </p:nvGraphicFramePr>
         <p:xfrm>
           <a:off x="457200" y="1554480"/>
-          <a:ext cx="11247120" cy="914400"/>
+          <a:ext cx="11247120" cy="1371600"/>
         </p:xfrm>
         <a:graphic>
           <a:graphicData uri="http://schemas.openxmlformats.org/drawingml/2006/table">
@@ -4076,6 +4076,71 @@
                   <a:tcPr marL="64008" marR="64008" marT="27432" marB="27432">
                     <a:solidFill>
                       <a:srgbClr val="FFFFFF"/>
+                    </a:solidFill>
+                  </a:tcPr>
+                </a:tc>
+              </a:tr>
+              <a:tr h="457200">
+                <a:tc>
+                  <a:txBody>
+                    <a:bodyPr wrap="square"/>
+                    <a:lstStyle/>
+                    <a:p>
+                      <a:r>
+                        <a:rPr sz="1100">
+                          <a:solidFill>
+                            <a:srgbClr val="1E293B"/>
+                          </a:solidFill>
+                        </a:rPr>
+                        <a:t>NOTA</a:t>
+                      </a:r>
+                    </a:p>
+                  </a:txBody>
+                  <a:tcPr marL="64008" marR="64008" marT="27432" marB="27432">
+                    <a:solidFill>
+                      <a:srgbClr val="F7F3EA"/>
+                    </a:solidFill>
+                  </a:tcPr>
+                </a:tc>
+                <a:tc>
+                  <a:txBody>
+                    <a:bodyPr wrap="square"/>
+                    <a:lstStyle/>
+                    <a:p>
+                      <a:r>
+                        <a:rPr sz="1100">
+                          <a:solidFill>
+                            <a:srgbClr val="1E293B"/>
+                          </a:solidFill>
+                        </a:rPr>
+                        <a:t>Biblias: las 2 de Camila</a:t>
+                      </a:r>
+                    </a:p>
+                  </a:txBody>
+                  <a:tcPr marL="64008" marR="64008" marT="27432" marB="27432">
+                    <a:solidFill>
+                      <a:srgbClr val="F7F3EA"/>
+                    </a:solidFill>
+                  </a:tcPr>
+                </a:tc>
+                <a:tc>
+                  <a:txBody>
+                    <a:bodyPr wrap="square"/>
+                    <a:lstStyle/>
+                    <a:p>
+                      <a:r>
+                        <a:rPr sz="1100">
+                          <a:solidFill>
+                            <a:srgbClr val="1E293B"/>
+                          </a:solidFill>
+                        </a:rPr>
+                        <a:t>Confirmar con Camila y con Juan Manuel: si ella puso 1,360 de su bolsillo, o se le reembolsa, o se registra como donación en especie (el costo del retiro subiría a 618,429 y la especie a 93,765). La caja y el cuadre con el banco no cambian en ningún caso.</a:t>
+                      </a:r>
+                    </a:p>
+                  </a:txBody>
+                  <a:tcPr marL="64008" marR="64008" marT="27432" marB="27432">
+                    <a:solidFill>
+                      <a:srgbClr val="F7F3EA"/>
                     </a:solidFill>
                   </a:tcPr>
                 </a:tc>
@@ -5178,7 +5243,7 @@
                             <a:srgbClr val="1E293B"/>
                           </a:solidFill>
                         </a:rPr>
-                        <a:t>36 verificaciones recalculadas al generar el archivo</a:t>
+                        <a:t>37 verificaciones recalculadas al generar el archivo</a:t>
                       </a:r>
                     </a:p>
                   </a:txBody>
@@ -6093,7 +6158,7 @@
                   <a:srgbClr val="1E293B"/>
                 </a:solidFill>
               </a:rPr>
-              <a:t>36 verificaciones se recalculan cada vez que se genera el archivo; 36 pasan y la restante es un dato pendiente, no un error de suma.</a:t>
+              <a:t>37 verificaciones se recalculan cada vez que se genera el archivo; 37 pasan y la restante es un dato pendiente, no un error de suma.</a:t>
             </a:r>
           </a:p>
           <a:p>

</xml_diff>

<commit_message>
Conciliación: restituida la nota de los 400 sin explicar en las habitaciones
Los 1,800 son firmes (lo que queda del pago a la casa). La tarifa de
900/noche está inferida de ahí, y el desglose verbal del 10-sep
(700 × 2 + 800 = 2,200) daría 400 más de lo que la casa cobró. Queda
como nota: una línea de la factura lo cierra y no afecta ningún total.

Con esto, los tres puntos blandos del cierre quedan visibles en el
documento: el reparto del impuesto, la tarifa de las habitaciones y las
2 biblias de Camila.

Co-Authored-By: Claude Opus 5 <noreply@anthropic.com>
Claude-Session: https://claude.ai/code/session_016scja59CycFFrqKgYsUPWh
</commit_message>
<xml_diff>
--- a/data/presupuesto/Conciliacion_ETC88_Presentacion.pptx
+++ b/data/presupuesto/Conciliacion_ETC88_Presentacion.pptx
@@ -3888,7 +3888,7 @@
                   <a:srgbClr val="888888"/>
                 </a:solidFill>
               </a:rPr>
-              <a:t>0 abiertos · 2 notas · el detalle completo está en la hoja 5 del Excel</a:t>
+              <a:t>0 abiertos · 3 notas · el detalle completo está en la hoja 5 del Excel</a:t>
             </a:r>
           </a:p>
         </p:txBody>
@@ -3937,7 +3937,7 @@
         </p:nvGraphicFramePr>
         <p:xfrm>
           <a:off x="457200" y="1554480"/>
-          <a:ext cx="11247120" cy="1371600"/>
+          <a:ext cx="11247120" cy="1828800"/>
         </p:xfrm>
         <a:graphic>
           <a:graphicData uri="http://schemas.openxmlformats.org/drawingml/2006/table">
@@ -4141,6 +4141,71 @@
                   <a:tcPr marL="64008" marR="64008" marT="27432" marB="27432">
                     <a:solidFill>
                       <a:srgbClr val="F7F3EA"/>
+                    </a:solidFill>
+                  </a:tcPr>
+                </a:tc>
+              </a:tr>
+              <a:tr h="457200">
+                <a:tc>
+                  <a:txBody>
+                    <a:bodyPr wrap="square"/>
+                    <a:lstStyle/>
+                    <a:p>
+                      <a:r>
+                        <a:rPr sz="1100">
+                          <a:solidFill>
+                            <a:srgbClr val="1E293B"/>
+                          </a:solidFill>
+                        </a:rPr>
+                        <a:t>NOTA</a:t>
+                      </a:r>
+                    </a:p>
+                  </a:txBody>
+                  <a:tcPr marL="64008" marR="64008" marT="27432" marB="27432">
+                    <a:solidFill>
+                      <a:srgbClr val="FFFFFF"/>
+                    </a:solidFill>
+                  </a:tcPr>
+                </a:tc>
+                <a:tc>
+                  <a:txBody>
+                    <a:bodyPr wrap="square"/>
+                    <a:lstStyle/>
+                    <a:p>
+                      <a:r>
+                        <a:rPr sz="1100">
+                          <a:solidFill>
+                            <a:srgbClr val="1E293B"/>
+                          </a:solidFill>
+                        </a:rPr>
+                        <a:t>Habitaciones de pequeños grupos: 400 sin explicar</a:t>
+                      </a:r>
+                    </a:p>
+                  </a:txBody>
+                  <a:tcPr marL="64008" marR="64008" marT="27432" marB="27432">
+                    <a:solidFill>
+                      <a:srgbClr val="FFFFFF"/>
+                    </a:solidFill>
+                  </a:tcPr>
+                </a:tc>
+                <a:tc>
+                  <a:txBody>
+                    <a:bodyPr wrap="square"/>
+                    <a:lstStyle/>
+                    <a:p>
+                      <a:r>
+                        <a:rPr sz="1100">
+                          <a:solidFill>
+                            <a:srgbClr val="1E293B"/>
+                          </a:solidFill>
+                        </a:rPr>
+                        <a:t>Una línea de la factura de la casa lo cierra. No afecta ningún total: lo pagado es lo pagado.</a:t>
+                      </a:r>
+                    </a:p>
+                  </a:txBody>
+                  <a:tcPr marL="64008" marR="64008" marT="27432" marB="27432">
+                    <a:solidFill>
+                      <a:srgbClr val="FFFFFF"/>
                     </a:solidFill>
                   </a:tcPr>
                 </a:tc>

</xml_diff>